<commit_message>
Exemplo por perfil: IAP e distância ao centroide nos dois municípios
Co-Authored-By: Claude Opus 5.5 <noreply@anthropic.com>
Claude-Session: https://claude.ai/code/session_01BauMyZR5unRwjRYRzKjEpf
</commit_message>
<xml_diff>
--- a/metodologia_cidades_inteligentes/apresentacao/Slide_exemplo_por_perfil.pptx
+++ b/metodologia_cidades_inteligentes/apresentacao/Slide_exemplo_por_perfil.pptx
@@ -963,7 +963,7 @@
         <p:spPr>
           <a:xfrm>
             <a:off x="731520" y="2337360"/>
-            <a:ext cx="2304288" cy="1010000"/>
+            <a:ext cx="2304288" cy="1190000"/>
           </a:xfrm>
           <a:prstGeom prst="roundRect">
             <a:avLst>
@@ -996,7 +996,7 @@
         <p:spPr>
           <a:xfrm>
             <a:off x="841520" y="2427360"/>
-            <a:ext cx="2084288" cy="900000"/>
+            <a:ext cx="2084288" cy="1070000"/>
           </a:xfrm>
           <a:prstGeom prst="rect">
             <a:avLst/>
@@ -1063,7 +1063,27 @@
                 </a:solidFill>
                 <a:latin typeface="Montserrat" pitchFamily="2" charset="0"/>
               </a:rPr>
-              <a:t>IAP = 1,712</a:t>
+              <a:t>IAP = 1,712 · 1º de 156</a:t>
+            </a:r>
+          </a:p>
+          <a:p>
+            <a:pPr marL="0" indent="0" algn="l">
+              <a:lnSpc>
+                <a:spcPct val="100000"/>
+              </a:lnSpc>
+              <a:spcAft>
+                <a:spcPts val="200"/>
+              </a:spcAft>
+              <a:buNone/>
+            </a:pPr>
+            <a:r>
+              <a:rPr lang="pt-BR" sz="1000" noProof="0">
+                <a:solidFill>
+                  <a:srgbClr val="E6E6E6"/>
+                </a:solidFill>
+                <a:latin typeface="Montserrat" pitchFamily="2" charset="0"/>
+              </a:rPr>
+              <a:t>Distância ao centroide = 0,892</a:t>
             </a:r>
           </a:p>
           <a:p>
@@ -1096,8 +1116,8 @@
         </p:nvSpPr>
         <p:spPr>
           <a:xfrm>
-            <a:off x="731520" y="3457360"/>
-            <a:ext cx="2304288" cy="1010000"/>
+            <a:off x="731520" y="3637360"/>
+            <a:ext cx="2304288" cy="1190000"/>
           </a:xfrm>
           <a:prstGeom prst="roundRect">
             <a:avLst>
@@ -1129,8 +1149,8 @@
         </p:nvSpPr>
         <p:spPr>
           <a:xfrm>
-            <a:off x="841520" y="3547360"/>
-            <a:ext cx="2084288" cy="900000"/>
+            <a:off x="841520" y="3727360"/>
+            <a:ext cx="2084288" cy="1070000"/>
           </a:xfrm>
           <a:prstGeom prst="rect">
             <a:avLst/>
@@ -1197,6 +1217,26 @@
                 </a:solidFill>
                 <a:latin typeface="Montserrat" pitchFamily="2" charset="0"/>
               </a:rPr>
+              <a:t>IAP = 0,824 · 75º de 156</a:t>
+            </a:r>
+          </a:p>
+          <a:p>
+            <a:pPr marL="0" indent="0" algn="l">
+              <a:lnSpc>
+                <a:spcPct val="100000"/>
+              </a:lnSpc>
+              <a:spcAft>
+                <a:spcPts val="200"/>
+              </a:spcAft>
+              <a:buNone/>
+            </a:pPr>
+            <a:r>
+              <a:rPr lang="pt-BR" sz="1000" noProof="0">
+                <a:solidFill>
+                  <a:srgbClr val="E6E6E6"/>
+                </a:solidFill>
+                <a:latin typeface="Montserrat" pitchFamily="2" charset="0"/>
+              </a:rPr>
               <a:t>Distância ao centroide = 0,099</a:t>
             </a:r>
           </a:p>
@@ -1217,7 +1257,7 @@
                 </a:solidFill>
                 <a:latin typeface="Montserrat" pitchFamily="2" charset="0"/>
               </a:rPr>
-              <a:t>IAP: 75º de 156</a:t>
+              <a:t>Representatividade: 1º de 156</a:t>
             </a:r>
           </a:p>
         </p:txBody>
@@ -1230,8 +1270,8 @@
         </p:nvSpPr>
         <p:spPr>
           <a:xfrm>
-            <a:off x="731520" y="4617360"/>
-            <a:ext cx="2304288" cy="1043360"/>
+            <a:off x="731520" y="4977360"/>
+            <a:ext cx="2304288" cy="683360"/>
           </a:xfrm>
           <a:prstGeom prst="rect">
             <a:avLst/>
@@ -1436,7 +1476,7 @@
         <p:spPr>
           <a:xfrm>
             <a:off x="3538728" y="2337360"/>
-            <a:ext cx="2304288" cy="1010000"/>
+            <a:ext cx="2304288" cy="1190000"/>
           </a:xfrm>
           <a:prstGeom prst="roundRect">
             <a:avLst>
@@ -1469,7 +1509,7 @@
         <p:spPr>
           <a:xfrm>
             <a:off x="3648728" y="2427360"/>
-            <a:ext cx="2084288" cy="900000"/>
+            <a:ext cx="2084288" cy="1070000"/>
           </a:xfrm>
           <a:prstGeom prst="rect">
             <a:avLst/>
@@ -1536,7 +1576,27 @@
                 </a:solidFill>
                 <a:latin typeface="Montserrat" pitchFamily="2" charset="0"/>
               </a:rPr>
-              <a:t>IAP = 1,781</a:t>
+              <a:t>IAP = 1,781 · 1º de 236</a:t>
+            </a:r>
+          </a:p>
+          <a:p>
+            <a:pPr marL="0" indent="0" algn="l">
+              <a:lnSpc>
+                <a:spcPct val="100000"/>
+              </a:lnSpc>
+              <a:spcAft>
+                <a:spcPts val="200"/>
+              </a:spcAft>
+              <a:buNone/>
+            </a:pPr>
+            <a:r>
+              <a:rPr lang="pt-BR" sz="1000" noProof="0">
+                <a:solidFill>
+                  <a:srgbClr val="E6E6E6"/>
+                </a:solidFill>
+                <a:latin typeface="Montserrat" pitchFamily="2" charset="0"/>
+              </a:rPr>
+              <a:t>Distância ao centroide = 1,538</a:t>
             </a:r>
           </a:p>
           <a:p>
@@ -1569,8 +1629,8 @@
         </p:nvSpPr>
         <p:spPr>
           <a:xfrm>
-            <a:off x="3538728" y="3457360"/>
-            <a:ext cx="2304288" cy="1010000"/>
+            <a:off x="3538728" y="3637360"/>
+            <a:ext cx="2304288" cy="1190000"/>
           </a:xfrm>
           <a:prstGeom prst="roundRect">
             <a:avLst>
@@ -1602,8 +1662,8 @@
         </p:nvSpPr>
         <p:spPr>
           <a:xfrm>
-            <a:off x="3648728" y="3547360"/>
-            <a:ext cx="2084288" cy="900000"/>
+            <a:off x="3648728" y="3727360"/>
+            <a:ext cx="2084288" cy="1070000"/>
           </a:xfrm>
           <a:prstGeom prst="rect">
             <a:avLst/>
@@ -1670,6 +1730,26 @@
                 </a:solidFill>
                 <a:latin typeface="Montserrat" pitchFamily="2" charset="0"/>
               </a:rPr>
+              <a:t>IAP = 0,230 · 124º de 236</a:t>
+            </a:r>
+          </a:p>
+          <a:p>
+            <a:pPr marL="0" indent="0" algn="l">
+              <a:lnSpc>
+                <a:spcPct val="100000"/>
+              </a:lnSpc>
+              <a:spcAft>
+                <a:spcPts val="200"/>
+              </a:spcAft>
+              <a:buNone/>
+            </a:pPr>
+            <a:r>
+              <a:rPr lang="pt-BR" sz="1000" noProof="0">
+                <a:solidFill>
+                  <a:srgbClr val="E6E6E6"/>
+                </a:solidFill>
+                <a:latin typeface="Montserrat" pitchFamily="2" charset="0"/>
+              </a:rPr>
               <a:t>Distância ao centroide = 0,051</a:t>
             </a:r>
           </a:p>
@@ -1690,7 +1770,7 @@
                 </a:solidFill>
                 <a:latin typeface="Montserrat" pitchFamily="2" charset="0"/>
               </a:rPr>
-              <a:t>IAP: 124º de 236</a:t>
+              <a:t>Representatividade: 1º de 236</a:t>
             </a:r>
           </a:p>
         </p:txBody>
@@ -1703,8 +1783,8 @@
         </p:nvSpPr>
         <p:spPr>
           <a:xfrm>
-            <a:off x="3538728" y="4617360"/>
-            <a:ext cx="2304288" cy="1043360"/>
+            <a:off x="3538728" y="4977360"/>
+            <a:ext cx="2304288" cy="683360"/>
           </a:xfrm>
           <a:prstGeom prst="rect">
             <a:avLst/>
@@ -1731,7 +1811,7 @@
                 </a:solidFill>
                 <a:latin typeface="Montserrat" pitchFamily="2" charset="0"/>
               </a:rPr>
-              <a:t>Iepê é o caso extremo do perfil (CFI muito alto, IMD e CSE muito baixos) e, por isso, o menos típico; Santa Cruz das Palmeiras está praticamente no centro do grupo.</a:t>
+              <a:t>Iepê é o caso extremo do perfil (CFI muito alto, IMD e CSE muito baixos); Santa Cruz das Palmeiras está no centro do grupo.</a:t>
             </a:r>
           </a:p>
         </p:txBody>
@@ -1909,7 +1989,7 @@
         <p:spPr>
           <a:xfrm>
             <a:off x="6345936" y="2337360"/>
-            <a:ext cx="2304288" cy="1010000"/>
+            <a:ext cx="2304288" cy="1190000"/>
           </a:xfrm>
           <a:prstGeom prst="roundRect">
             <a:avLst>
@@ -1942,7 +2022,7 @@
         <p:spPr>
           <a:xfrm>
             <a:off x="6455936" y="2427360"/>
-            <a:ext cx="2084288" cy="900000"/>
+            <a:ext cx="2084288" cy="1070000"/>
           </a:xfrm>
           <a:prstGeom prst="rect">
             <a:avLst/>
@@ -2009,7 +2089,27 @@
                 </a:solidFill>
                 <a:latin typeface="Montserrat" pitchFamily="2" charset="0"/>
               </a:rPr>
-              <a:t>IAP = 1,939</a:t>
+              <a:t>IAP = 1,939 · 1º de 180</a:t>
+            </a:r>
+          </a:p>
+          <a:p>
+            <a:pPr marL="0" indent="0" algn="l">
+              <a:lnSpc>
+                <a:spcPct val="100000"/>
+              </a:lnSpc>
+              <a:spcAft>
+                <a:spcPts val="200"/>
+              </a:spcAft>
+              <a:buNone/>
+            </a:pPr>
+            <a:r>
+              <a:rPr lang="pt-BR" sz="1000" noProof="0">
+                <a:solidFill>
+                  <a:srgbClr val="E6E6E6"/>
+                </a:solidFill>
+                <a:latin typeface="Montserrat" pitchFamily="2" charset="0"/>
+              </a:rPr>
+              <a:t>Distância ao centroide = 1,339</a:t>
             </a:r>
           </a:p>
           <a:p>
@@ -2042,8 +2142,8 @@
         </p:nvSpPr>
         <p:spPr>
           <a:xfrm>
-            <a:off x="6345936" y="3457360"/>
-            <a:ext cx="2304288" cy="1010000"/>
+            <a:off x="6345936" y="3637360"/>
+            <a:ext cx="2304288" cy="1190000"/>
           </a:xfrm>
           <a:prstGeom prst="roundRect">
             <a:avLst>
@@ -2075,8 +2175,8 @@
         </p:nvSpPr>
         <p:spPr>
           <a:xfrm>
-            <a:off x="6455936" y="3547360"/>
-            <a:ext cx="2084288" cy="900000"/>
+            <a:off x="6455936" y="3727360"/>
+            <a:ext cx="2084288" cy="1070000"/>
           </a:xfrm>
           <a:prstGeom prst="rect">
             <a:avLst/>
@@ -2143,6 +2243,26 @@
                 </a:solidFill>
                 <a:latin typeface="Montserrat" pitchFamily="2" charset="0"/>
               </a:rPr>
+              <a:t>IAP = 1,040 · 51º de 180</a:t>
+            </a:r>
+          </a:p>
+          <a:p>
+            <a:pPr marL="0" indent="0" algn="l">
+              <a:lnSpc>
+                <a:spcPct val="100000"/>
+              </a:lnSpc>
+              <a:spcAft>
+                <a:spcPts val="200"/>
+              </a:spcAft>
+              <a:buNone/>
+            </a:pPr>
+            <a:r>
+              <a:rPr lang="pt-BR" sz="1000" noProof="0">
+                <a:solidFill>
+                  <a:srgbClr val="E6E6E6"/>
+                </a:solidFill>
+                <a:latin typeface="Montserrat" pitchFamily="2" charset="0"/>
+              </a:rPr>
               <a:t>Distância ao centroide = 0,243</a:t>
             </a:r>
           </a:p>
@@ -2163,7 +2283,7 @@
                 </a:solidFill>
                 <a:latin typeface="Montserrat" pitchFamily="2" charset="0"/>
               </a:rPr>
-              <a:t>IAP: 51º de 180</a:t>
+              <a:t>Representatividade: 1º de 180</a:t>
             </a:r>
           </a:p>
         </p:txBody>
@@ -2176,8 +2296,8 @@
         </p:nvSpPr>
         <p:spPr>
           <a:xfrm>
-            <a:off x="6345936" y="4617360"/>
-            <a:ext cx="2304288" cy="1043360"/>
+            <a:off x="6345936" y="4977360"/>
+            <a:ext cx="2304288" cy="683360"/>
           </a:xfrm>
           <a:prstGeom prst="rect">
             <a:avLst/>
@@ -2204,7 +2324,7 @@
                 </a:solidFill>
                 <a:latin typeface="Montserrat" pitchFamily="2" charset="0"/>
               </a:rPr>
-              <a:t>Sorocaba tem forte alinhamento às direções do Perfil C, mas se afasta da combinação média; Barra Bonita é o que mais se aproxima do padrão do grupo.</a:t>
+              <a:t>Sorocaba é forte nas direções do Perfil C, mas foge da combinação média; Barra Bonita é a mais próxima do padrão do grupo.</a:t>
             </a:r>
           </a:p>
         </p:txBody>
@@ -2382,7 +2502,7 @@
         <p:spPr>
           <a:xfrm>
             <a:off x="9153144" y="2337360"/>
-            <a:ext cx="2304288" cy="1010000"/>
+            <a:ext cx="2304288" cy="1190000"/>
           </a:xfrm>
           <a:prstGeom prst="roundRect">
             <a:avLst>
@@ -2415,7 +2535,7 @@
         <p:spPr>
           <a:xfrm>
             <a:off x="9263144" y="2427360"/>
-            <a:ext cx="2084288" cy="900000"/>
+            <a:ext cx="2084288" cy="1070000"/>
           </a:xfrm>
           <a:prstGeom prst="rect">
             <a:avLst/>
@@ -2482,7 +2602,27 @@
                 </a:solidFill>
                 <a:latin typeface="Montserrat" pitchFamily="2" charset="0"/>
               </a:rPr>
-              <a:t>IAP = 2,578</a:t>
+              <a:t>IAP = 2,578 · 1º de 72</a:t>
+            </a:r>
+          </a:p>
+          <a:p>
+            <a:pPr marL="0" indent="0" algn="l">
+              <a:lnSpc>
+                <a:spcPct val="100000"/>
+              </a:lnSpc>
+              <a:spcAft>
+                <a:spcPts val="200"/>
+              </a:spcAft>
+              <a:buNone/>
+            </a:pPr>
+            <a:r>
+              <a:rPr lang="pt-BR" sz="1000" noProof="0">
+                <a:solidFill>
+                  <a:srgbClr val="E6E6E6"/>
+                </a:solidFill>
+                <a:latin typeface="Montserrat" pitchFamily="2" charset="0"/>
+              </a:rPr>
+              <a:t>Distância ao centroide = 1,934</a:t>
             </a:r>
           </a:p>
           <a:p>
@@ -2515,8 +2655,8 @@
         </p:nvSpPr>
         <p:spPr>
           <a:xfrm>
-            <a:off x="9153144" y="3457360"/>
-            <a:ext cx="2304288" cy="1010000"/>
+            <a:off x="9153144" y="3637360"/>
+            <a:ext cx="2304288" cy="1190000"/>
           </a:xfrm>
           <a:prstGeom prst="roundRect">
             <a:avLst>
@@ -2548,8 +2688,8 @@
         </p:nvSpPr>
         <p:spPr>
           <a:xfrm>
-            <a:off x="9263144" y="3547360"/>
-            <a:ext cx="2084288" cy="900000"/>
+            <a:off x="9263144" y="3727360"/>
+            <a:ext cx="2084288" cy="1070000"/>
           </a:xfrm>
           <a:prstGeom prst="rect">
             <a:avLst/>
@@ -2616,6 +2756,26 @@
                 </a:solidFill>
                 <a:latin typeface="Montserrat" pitchFamily="2" charset="0"/>
               </a:rPr>
+              <a:t>IAP = 0,887 · 27º de 72</a:t>
+            </a:r>
+          </a:p>
+          <a:p>
+            <a:pPr marL="0" indent="0" algn="l">
+              <a:lnSpc>
+                <a:spcPct val="100000"/>
+              </a:lnSpc>
+              <a:spcAft>
+                <a:spcPts val="200"/>
+              </a:spcAft>
+              <a:buNone/>
+            </a:pPr>
+            <a:r>
+              <a:rPr lang="pt-BR" sz="1000" noProof="0">
+                <a:solidFill>
+                  <a:srgbClr val="E6E6E6"/>
+                </a:solidFill>
+                <a:latin typeface="Montserrat" pitchFamily="2" charset="0"/>
+              </a:rPr>
               <a:t>Distância ao centroide = 0,122</a:t>
             </a:r>
           </a:p>
@@ -2636,7 +2796,7 @@
                 </a:solidFill>
                 <a:latin typeface="Montserrat" pitchFamily="2" charset="0"/>
               </a:rPr>
-              <a:t>IAP: 27º de 72</a:t>
+              <a:t>Representatividade: 1º de 72</a:t>
             </a:r>
           </a:p>
         </p:txBody>
@@ -2649,8 +2809,8 @@
         </p:nvSpPr>
         <p:spPr>
           <a:xfrm>
-            <a:off x="9153144" y="4617360"/>
-            <a:ext cx="2304288" cy="1043360"/>
+            <a:off x="9153144" y="4977360"/>
+            <a:ext cx="2304288" cy="683360"/>
           </a:xfrm>
           <a:prstGeom prst="rect">
             <a:avLst/>

</xml_diff>